<commit_message>
Cambio color rojo a azul
</commit_message>
<xml_diff>
--- a/Canva/Red and White Modern Sustainable Footwear Pitch Deck Presentation.pptx
+++ b/Canva/Red and White Modern Sustainable Footwear Pitch Deck Presentation.pptx
@@ -3173,7 +3173,7 @@
               </a:pathLst>
             </a:custGeom>
             <a:solidFill>
-              <a:srgbClr val="7A0D0D"/>
+              <a:srgbClr val="103777"/>
             </a:solidFill>
           </p:spPr>
         </p:sp>
@@ -3260,12 +3260,12 @@
             <a:gradFill rotWithShape="true">
               <a:gsLst>
                 <a:gs pos="0">
-                  <a:srgbClr val="A82727">
+                  <a:srgbClr val="2657A7">
                     <a:alpha val="100000"/>
                   </a:srgbClr>
                 </a:gs>
                 <a:gs pos="100000">
-                  <a:srgbClr val="A82727">
+                  <a:srgbClr val="2657A9">
                     <a:alpha val="0"/>
                   </a:srgbClr>
                 </a:gs>
@@ -3357,12 +3357,12 @@
             <a:gradFill rotWithShape="true">
               <a:gsLst>
                 <a:gs pos="0">
-                  <a:srgbClr val="A82727">
+                  <a:srgbClr val="2756A2">
                     <a:alpha val="100000"/>
                   </a:srgbClr>
                 </a:gs>
                 <a:gs pos="100000">
-                  <a:srgbClr val="A82727">
+                  <a:srgbClr val="2554A2">
                     <a:alpha val="0"/>
                   </a:srgbClr>
                 </a:gs>
@@ -3657,12 +3657,12 @@
             <a:gradFill rotWithShape="true">
               <a:gsLst>
                 <a:gs pos="0">
-                  <a:srgbClr val="E14434">
+                  <a:srgbClr val="3B82F6">
                     <a:alpha val="100000"/>
                   </a:srgbClr>
                 </a:gs>
                 <a:gs pos="100000">
-                  <a:srgbClr val="E14434">
+                  <a:srgbClr val="3B82F6">
                     <a:alpha val="25000"/>
                   </a:srgbClr>
                 </a:gs>
@@ -3670,21 +3670,9 @@
               <a:lin ang="0"/>
             </a:gradFill>
             <a:ln w="19050" cap="sq">
-              <a:gradFill>
-                <a:gsLst>
-                  <a:gs pos="0">
-                    <a:srgbClr val="E14434">
-                      <a:alpha val="100000"/>
-                    </a:srgbClr>
-                  </a:gs>
-                  <a:gs pos="100000">
-                    <a:srgbClr val="E14434">
-                      <a:alpha val="100000"/>
-                    </a:srgbClr>
-                  </a:gs>
-                </a:gsLst>
-                <a:lin ang="0"/>
-              </a:gradFill>
+              <a:solidFill>
+                <a:srgbClr val="F5F5F5"/>
+              </a:solidFill>
               <a:prstDash val="solid"/>
               <a:miter/>
             </a:ln>
@@ -4117,7 +4105,7 @@
               </a:pathLst>
             </a:custGeom>
             <a:solidFill>
-              <a:srgbClr val="7A0D0D"/>
+              <a:srgbClr val="113B7F"/>
             </a:solidFill>
           </p:spPr>
         </p:sp>
@@ -4204,12 +4192,12 @@
             <a:gradFill rotWithShape="true">
               <a:gsLst>
                 <a:gs pos="0">
-                  <a:srgbClr val="A82727">
+                  <a:srgbClr val="2757A4">
                     <a:alpha val="100000"/>
                   </a:srgbClr>
                 </a:gs>
                 <a:gs pos="100000">
-                  <a:srgbClr val="A82727">
+                  <a:srgbClr val="295BAD">
                     <a:alpha val="0"/>
                   </a:srgbClr>
                 </a:gs>
@@ -4301,12 +4289,12 @@
             <a:gradFill rotWithShape="true">
               <a:gsLst>
                 <a:gs pos="0">
-                  <a:srgbClr val="A82727">
+                  <a:srgbClr val="3B82F6">
                     <a:alpha val="100000"/>
                   </a:srgbClr>
                 </a:gs>
                 <a:gs pos="100000">
-                  <a:srgbClr val="A82727">
+                  <a:srgbClr val="295CAF">
                     <a:alpha val="0"/>
                   </a:srgbClr>
                 </a:gs>
@@ -4398,12 +4386,12 @@
             <a:gradFill rotWithShape="true">
               <a:gsLst>
                 <a:gs pos="0">
-                  <a:srgbClr val="A82727">
+                  <a:srgbClr val="22509B">
                     <a:alpha val="100000"/>
                   </a:srgbClr>
                 </a:gs>
                 <a:gs pos="100000">
-                  <a:srgbClr val="A82727">
+                  <a:srgbClr val="285AAB">
                     <a:alpha val="0"/>
                   </a:srgbClr>
                 </a:gs>
@@ -4493,7 +4481,7 @@
               </a:pathLst>
             </a:custGeom>
             <a:solidFill>
-              <a:srgbClr val="E14434"/>
+              <a:srgbClr val="3B82F6"/>
             </a:solidFill>
           </p:spPr>
         </p:sp>
@@ -4590,7 +4578,7 @@
               </a:pathLst>
             </a:custGeom>
             <a:solidFill>
-              <a:srgbClr val="E14434"/>
+              <a:srgbClr val="3B82F6"/>
             </a:solidFill>
           </p:spPr>
         </p:sp>
@@ -4687,7 +4675,7 @@
               </a:pathLst>
             </a:custGeom>
             <a:solidFill>
-              <a:srgbClr val="E14434"/>
+              <a:srgbClr val="3B82F6"/>
             </a:solidFill>
           </p:spPr>
         </p:sp>
@@ -4784,7 +4772,7 @@
               </a:pathLst>
             </a:custGeom>
             <a:solidFill>
-              <a:srgbClr val="E14434"/>
+              <a:srgbClr val="3B82F6"/>
             </a:solidFill>
           </p:spPr>
         </p:sp>
@@ -4836,7 +4824,7 @@
         </p:nvSpPr>
         <p:spPr>
           <a:xfrm rot="0">
-            <a:off x="1028700" y="4013200"/>
+            <a:off x="1028700" y="4792104"/>
             <a:ext cx="5214371" cy="1289049"/>
           </a:xfrm>
           <a:prstGeom prst="rect">

</xml_diff>